<commit_message>
Update line tracking slides: replace PDF blueprint with pptx versions and add object composition slides
Co-Authored-By: Claude Opus 4.6 <noreply@anthropic.com>
</commit_message>
<xml_diff>
--- a/module-02-line-tracking/slides/10-final-project.pptx
+++ b/module-02-line-tracking/slides/10-final-project.pptx
@@ -78,7 +78,7 @@
         <a:sym typeface="Calibri"/>
       </a:defRPr>
     </a:lvl1pPr>
-    <a:lvl2pPr marL="0" marR="0" indent="457200" algn="l" defTabSz="457200" rtl="0" fontAlgn="auto" latinLnBrk="0" hangingPunct="0">
+    <a:lvl2pPr marL="0" marR="0" indent="0" algn="l" defTabSz="457200" rtl="0" fontAlgn="auto" latinLnBrk="0" hangingPunct="0">
       <a:lnSpc>
         <a:spcPct val="100000"/>
       </a:lnSpc>
@@ -108,7 +108,7 @@
         <a:sym typeface="Calibri"/>
       </a:defRPr>
     </a:lvl2pPr>
-    <a:lvl3pPr marL="0" marR="0" indent="914400" algn="l" defTabSz="457200" rtl="0" fontAlgn="auto" latinLnBrk="0" hangingPunct="0">
+    <a:lvl3pPr marL="0" marR="0" indent="0" algn="l" defTabSz="457200" rtl="0" fontAlgn="auto" latinLnBrk="0" hangingPunct="0">
       <a:lnSpc>
         <a:spcPct val="100000"/>
       </a:lnSpc>
@@ -138,7 +138,7 @@
         <a:sym typeface="Calibri"/>
       </a:defRPr>
     </a:lvl3pPr>
-    <a:lvl4pPr marL="0" marR="0" indent="1371600" algn="l" defTabSz="457200" rtl="0" fontAlgn="auto" latinLnBrk="0" hangingPunct="0">
+    <a:lvl4pPr marL="0" marR="0" indent="0" algn="l" defTabSz="457200" rtl="0" fontAlgn="auto" latinLnBrk="0" hangingPunct="0">
       <a:lnSpc>
         <a:spcPct val="100000"/>
       </a:lnSpc>
@@ -168,7 +168,7 @@
         <a:sym typeface="Calibri"/>
       </a:defRPr>
     </a:lvl4pPr>
-    <a:lvl5pPr marL="0" marR="0" indent="1828800" algn="l" defTabSz="457200" rtl="0" fontAlgn="auto" latinLnBrk="0" hangingPunct="0">
+    <a:lvl5pPr marL="0" marR="0" indent="0" algn="l" defTabSz="457200" rtl="0" fontAlgn="auto" latinLnBrk="0" hangingPunct="0">
       <a:lnSpc>
         <a:spcPct val="100000"/>
       </a:lnSpc>
@@ -198,7 +198,7 @@
         <a:sym typeface="Calibri"/>
       </a:defRPr>
     </a:lvl5pPr>
-    <a:lvl6pPr marL="0" marR="0" indent="2286000" algn="l" defTabSz="457200" rtl="0" fontAlgn="auto" latinLnBrk="0" hangingPunct="0">
+    <a:lvl6pPr marL="0" marR="0" indent="0" algn="l" defTabSz="457200" rtl="0" fontAlgn="auto" latinLnBrk="0" hangingPunct="0">
       <a:lnSpc>
         <a:spcPct val="100000"/>
       </a:lnSpc>
@@ -228,7 +228,7 @@
         <a:sym typeface="Calibri"/>
       </a:defRPr>
     </a:lvl6pPr>
-    <a:lvl7pPr marL="0" marR="0" indent="2743200" algn="l" defTabSz="457200" rtl="0" fontAlgn="auto" latinLnBrk="0" hangingPunct="0">
+    <a:lvl7pPr marL="0" marR="0" indent="0" algn="l" defTabSz="457200" rtl="0" fontAlgn="auto" latinLnBrk="0" hangingPunct="0">
       <a:lnSpc>
         <a:spcPct val="100000"/>
       </a:lnSpc>
@@ -258,7 +258,7 @@
         <a:sym typeface="Calibri"/>
       </a:defRPr>
     </a:lvl7pPr>
-    <a:lvl8pPr marL="0" marR="0" indent="3200400" algn="l" defTabSz="457200" rtl="0" fontAlgn="auto" latinLnBrk="0" hangingPunct="0">
+    <a:lvl8pPr marL="0" marR="0" indent="0" algn="l" defTabSz="457200" rtl="0" fontAlgn="auto" latinLnBrk="0" hangingPunct="0">
       <a:lnSpc>
         <a:spcPct val="100000"/>
       </a:lnSpc>
@@ -288,7 +288,7 @@
         <a:sym typeface="Calibri"/>
       </a:defRPr>
     </a:lvl8pPr>
-    <a:lvl9pPr marL="0" marR="0" indent="3657600" algn="l" defTabSz="457200" rtl="0" fontAlgn="auto" latinLnBrk="0" hangingPunct="0">
+    <a:lvl9pPr marL="0" marR="0" indent="0" algn="l" defTabSz="457200" rtl="0" fontAlgn="auto" latinLnBrk="0" hangingPunct="0">
       <a:lnSpc>
         <a:spcPct val="100000"/>
       </a:lnSpc>
@@ -548,7 +548,7 @@
                 </a:solidFill>
               </a:defRPr>
             </a:lvl1pPr>
-            <a:lvl2pPr marL="0" indent="457200" algn="ctr">
+            <a:lvl2pPr marL="0" indent="0" algn="ctr">
               <a:buSzTx/>
               <a:buFontTx/>
               <a:buNone/>
@@ -558,7 +558,7 @@
                 </a:solidFill>
               </a:defRPr>
             </a:lvl2pPr>
-            <a:lvl3pPr marL="0" indent="914400" algn="ctr">
+            <a:lvl3pPr marL="0" indent="0" algn="ctr">
               <a:buSzTx/>
               <a:buFontTx/>
               <a:buNone/>
@@ -568,7 +568,7 @@
                 </a:solidFill>
               </a:defRPr>
             </a:lvl3pPr>
-            <a:lvl4pPr marL="0" indent="1371600" algn="ctr">
+            <a:lvl4pPr marL="0" indent="0" algn="ctr">
               <a:buSzTx/>
               <a:buFontTx/>
               <a:buNone/>
@@ -578,7 +578,7 @@
                 </a:solidFill>
               </a:defRPr>
             </a:lvl4pPr>
-            <a:lvl5pPr marL="0" indent="1828800" algn="ctr">
+            <a:lvl5pPr marL="0" indent="0" algn="ctr">
               <a:buSzTx/>
               <a:buFontTx/>
               <a:buNone/>
@@ -678,10 +678,6 @@
           </p:nvPr>
         </p:nvSpPr>
         <p:spPr>
-          <a:xfrm>
-            <a:off x="457200" y="274638"/>
-            <a:ext cx="8229600" cy="1143001"/>
-          </a:xfrm>
           <a:prstGeom prst="rect">
             <a:avLst/>
           </a:prstGeom>
@@ -706,10 +702,6 @@
           </p:nvPr>
         </p:nvSpPr>
         <p:spPr>
-          <a:xfrm>
-            <a:off x="457200" y="1600200"/>
-            <a:ext cx="8229600" cy="4525963"/>
-          </a:xfrm>
           <a:prstGeom prst="rect">
             <a:avLst/>
           </a:prstGeom>
@@ -840,7 +832,7 @@
         <p:spPr>
           <a:xfrm>
             <a:off x="722312" y="2906713"/>
-            <a:ext cx="7772401" cy="1500188"/>
+            <a:ext cx="7772401" cy="1500189"/>
           </a:xfrm>
           <a:prstGeom prst="rect">
             <a:avLst/>
@@ -862,7 +854,7 @@
                 </a:solidFill>
               </a:defRPr>
             </a:lvl1pPr>
-            <a:lvl2pPr marL="0" indent="457200">
+            <a:lvl2pPr marL="0" indent="0">
               <a:spcBef>
                 <a:spcPts val="400"/>
               </a:spcBef>
@@ -875,7 +867,7 @@
                 </a:solidFill>
               </a:defRPr>
             </a:lvl2pPr>
-            <a:lvl3pPr marL="0" indent="914400">
+            <a:lvl3pPr marL="0" indent="0">
               <a:spcBef>
                 <a:spcPts val="400"/>
               </a:spcBef>
@@ -888,7 +880,7 @@
                 </a:solidFill>
               </a:defRPr>
             </a:lvl3pPr>
-            <a:lvl4pPr marL="0" indent="1371600">
+            <a:lvl4pPr marL="0" indent="0">
               <a:spcBef>
                 <a:spcPts val="400"/>
               </a:spcBef>
@@ -901,7 +893,7 @@
                 </a:solidFill>
               </a:defRPr>
             </a:lvl4pPr>
-            <a:lvl5pPr marL="0" indent="1828800">
+            <a:lvl5pPr marL="0" indent="0">
               <a:spcBef>
                 <a:spcPts val="400"/>
               </a:spcBef>
@@ -1004,10 +996,6 @@
           </p:nvPr>
         </p:nvSpPr>
         <p:spPr>
-          <a:xfrm>
-            <a:off x="457200" y="274638"/>
-            <a:ext cx="8229600" cy="1143001"/>
-          </a:xfrm>
           <a:prstGeom prst="rect">
             <a:avLst/>
           </a:prstGeom>
@@ -1055,7 +1043,7 @@
               </a:spcBef>
               <a:defRPr sz="2800"/>
             </a:lvl2pPr>
-            <a:lvl3pPr marL="1234439" indent="-320039">
+            <a:lvl3pPr marL="1234438" indent="-320038">
               <a:spcBef>
                 <a:spcPts val="600"/>
               </a:spcBef>
@@ -1163,10 +1151,6 @@
           </p:nvPr>
         </p:nvSpPr>
         <p:spPr>
-          <a:xfrm>
-            <a:off x="457200" y="274638"/>
-            <a:ext cx="8229600" cy="1143001"/>
-          </a:xfrm>
           <a:prstGeom prst="rect">
             <a:avLst/>
           </a:prstGeom>
@@ -1211,7 +1195,7 @@
               <a:buNone/>
               <a:defRPr b="1" sz="2400"/>
             </a:lvl1pPr>
-            <a:lvl2pPr marL="0" indent="457200">
+            <a:lvl2pPr marL="0" indent="0">
               <a:spcBef>
                 <a:spcPts val="500"/>
               </a:spcBef>
@@ -1220,7 +1204,7 @@
               <a:buNone/>
               <a:defRPr b="1" sz="2400"/>
             </a:lvl2pPr>
-            <a:lvl3pPr marL="0" indent="914400">
+            <a:lvl3pPr marL="0" indent="0">
               <a:spcBef>
                 <a:spcPts val="500"/>
               </a:spcBef>
@@ -1229,7 +1213,7 @@
               <a:buNone/>
               <a:defRPr b="1" sz="2400"/>
             </a:lvl3pPr>
-            <a:lvl4pPr marL="0" indent="1371600">
+            <a:lvl4pPr marL="0" indent="0">
               <a:spcBef>
                 <a:spcPts val="500"/>
               </a:spcBef>
@@ -1238,7 +1222,7 @@
               <a:buNone/>
               <a:defRPr b="1" sz="2400"/>
             </a:lvl4pPr>
-            <a:lvl5pPr marL="0" indent="1828800">
+            <a:lvl5pPr marL="0" indent="0">
               <a:spcBef>
                 <a:spcPts val="500"/>
               </a:spcBef>
@@ -1290,8 +1274,8 @@
         </p:nvSpPr>
         <p:spPr>
           <a:xfrm>
-            <a:off x="4645025" y="1535112"/>
-            <a:ext cx="4041775" cy="639763"/>
+            <a:off x="4645025" y="1535111"/>
+            <a:ext cx="4041775" cy="639765"/>
           </a:xfrm>
           <a:prstGeom prst="rect">
             <a:avLst/>
@@ -1301,15 +1285,7 @@
           <a:bodyPr anchor="b"/>
           <a:lstStyle/>
           <a:p>
-            <a:pPr marL="0" indent="0">
-              <a:spcBef>
-                <a:spcPts val="500"/>
-              </a:spcBef>
-              <a:buSzTx/>
-              <a:buFontTx/>
-              <a:buNone/>
-              <a:defRPr b="1" sz="2400"/>
-            </a:pPr>
+            <a:pPr/>
           </a:p>
         </p:txBody>
       </p:sp>
@@ -1370,10 +1346,6 @@
           </p:nvPr>
         </p:nvSpPr>
         <p:spPr>
-          <a:xfrm>
-            <a:off x="457200" y="274638"/>
-            <a:ext cx="8229600" cy="1143001"/>
-          </a:xfrm>
           <a:prstGeom prst="rect">
             <a:avLst/>
           </a:prstGeom>
@@ -1496,7 +1468,7 @@
         <p:spPr>
           <a:xfrm>
             <a:off x="457200" y="273050"/>
-            <a:ext cx="3008314" cy="1162050"/>
+            <a:ext cx="3008315" cy="1162050"/>
           </a:xfrm>
           <a:prstGeom prst="rect">
             <a:avLst/>
@@ -1579,8 +1551,8 @@
         </p:nvSpPr>
         <p:spPr>
           <a:xfrm>
-            <a:off x="457199" y="1435100"/>
-            <a:ext cx="3008315" cy="4691063"/>
+            <a:off x="457198" y="1435100"/>
+            <a:ext cx="3008316" cy="4691063"/>
           </a:xfrm>
           <a:prstGeom prst="rect">
             <a:avLst/>
@@ -1590,15 +1562,7 @@
           <a:bodyPr/>
           <a:lstStyle/>
           <a:p>
-            <a:pPr marL="0" indent="0">
-              <a:spcBef>
-                <a:spcPts val="300"/>
-              </a:spcBef>
-              <a:buSzTx/>
-              <a:buFontTx/>
-              <a:buNone/>
-              <a:defRPr sz="1400"/>
-            </a:pPr>
+            <a:pPr/>
           </a:p>
         </p:txBody>
       </p:sp>
@@ -1661,7 +1625,7 @@
         <p:spPr>
           <a:xfrm>
             <a:off x="1792288" y="4800600"/>
-            <a:ext cx="5486401" cy="566738"/>
+            <a:ext cx="5486402" cy="566738"/>
           </a:xfrm>
           <a:prstGeom prst="rect">
             <a:avLst/>
@@ -1693,14 +1657,14 @@
         <p:spPr>
           <a:xfrm>
             <a:off x="1792288" y="612775"/>
-            <a:ext cx="5486401" cy="4114800"/>
+            <a:ext cx="5486402" cy="4114800"/>
           </a:xfrm>
           <a:prstGeom prst="rect">
             <a:avLst/>
           </a:prstGeom>
         </p:spPr>
         <p:txBody>
-          <a:bodyPr lIns="91439" rIns="91439">
+          <a:bodyPr lIns="91439" tIns="45719" rIns="91439" bIns="45719">
             <a:noAutofit/>
           </a:bodyPr>
           <a:lstStyle/>
@@ -1720,7 +1684,7 @@
         <p:spPr>
           <a:xfrm>
             <a:off x="1792288" y="5367337"/>
-            <a:ext cx="5486401" cy="804863"/>
+            <a:ext cx="5486402" cy="804864"/>
           </a:xfrm>
           <a:prstGeom prst="rect">
             <a:avLst/>
@@ -1738,7 +1702,7 @@
               <a:buNone/>
               <a:defRPr sz="1400"/>
             </a:lvl1pPr>
-            <a:lvl2pPr marL="0" indent="457200">
+            <a:lvl2pPr marL="0" indent="0">
               <a:spcBef>
                 <a:spcPts val="300"/>
               </a:spcBef>
@@ -1747,7 +1711,7 @@
               <a:buNone/>
               <a:defRPr sz="1400"/>
             </a:lvl2pPr>
-            <a:lvl3pPr marL="0" indent="914400">
+            <a:lvl3pPr marL="0" indent="0">
               <a:spcBef>
                 <a:spcPts val="300"/>
               </a:spcBef>
@@ -1756,7 +1720,7 @@
               <a:buNone/>
               <a:defRPr sz="1400"/>
             </a:lvl3pPr>
-            <a:lvl4pPr marL="0" indent="1371600">
+            <a:lvl4pPr marL="0" indent="0">
               <a:spcBef>
                 <a:spcPts val="300"/>
               </a:spcBef>
@@ -1765,7 +1729,7 @@
               <a:buNone/>
               <a:defRPr sz="1400"/>
             </a:lvl4pPr>
-            <a:lvl5pPr marL="0" indent="1828800">
+            <a:lvl5pPr marL="0" indent="0">
               <a:spcBef>
                 <a:spcPts val="300"/>
               </a:spcBef>
@@ -1872,8 +1836,8 @@
         </p:nvSpPr>
         <p:spPr>
           <a:xfrm>
-            <a:off x="608965" y="92074"/>
-            <a:ext cx="10961370" cy="1508127"/>
+            <a:off x="457200" y="274638"/>
+            <a:ext cx="8229600" cy="1143001"/>
           </a:xfrm>
           <a:prstGeom prst="rect">
             <a:avLst/>
@@ -1888,7 +1852,7 @@
           </a:extLst>
         </p:spPr>
         <p:txBody>
-          <a:bodyPr lIns="45719" rIns="45719" anchor="ctr">
+          <a:bodyPr lIns="45718" tIns="45718" rIns="45718" bIns="45718" anchor="ctr">
             <a:normAutofit fontScale="100000" lnSpcReduction="0"/>
           </a:bodyPr>
           <a:lstStyle/>
@@ -1910,8 +1874,8 @@
         </p:nvSpPr>
         <p:spPr>
           <a:xfrm>
-            <a:off x="608965" y="1600200"/>
-            <a:ext cx="10961370" cy="5257800"/>
+            <a:off x="457200" y="1600200"/>
+            <a:ext cx="8229600" cy="4525963"/>
           </a:xfrm>
           <a:prstGeom prst="rect">
             <a:avLst/>
@@ -1926,7 +1890,7 @@
           </a:extLst>
         </p:spPr>
         <p:txBody>
-          <a:bodyPr lIns="45719" rIns="45719">
+          <a:bodyPr lIns="45718" tIns="45718" rIns="45718" bIns="45718">
             <a:normAutofit fontScale="100000" lnSpcReduction="0"/>
           </a:bodyPr>
           <a:lstStyle/>
@@ -1972,8 +1936,8 @@
         </p:nvSpPr>
         <p:spPr>
           <a:xfrm>
-            <a:off x="8428176" y="6414760"/>
-            <a:ext cx="258624" cy="248305"/>
+            <a:off x="8428178" y="6414761"/>
+            <a:ext cx="258623" cy="248303"/>
           </a:xfrm>
           <a:prstGeom prst="rect">
             <a:avLst/>
@@ -1983,7 +1947,7 @@
           </a:ln>
         </p:spPr>
         <p:txBody>
-          <a:bodyPr wrap="none" lIns="45719" rIns="45719" anchor="ctr">
+          <a:bodyPr wrap="none" lIns="45718" tIns="45718" rIns="45718" bIns="45718" anchor="ctr">
             <a:spAutoFit/>
           </a:bodyPr>
           <a:lstStyle>
@@ -2516,7 +2480,7 @@
           <a:sym typeface="Calibri"/>
         </a:defRPr>
       </a:lvl1pPr>
-      <a:lvl2pPr marL="0" marR="0" indent="457200" algn="r" defTabSz="457200" rtl="0" latinLnBrk="0">
+      <a:lvl2pPr marL="0" marR="0" indent="0" algn="r" defTabSz="457200" rtl="0" latinLnBrk="0">
         <a:lnSpc>
           <a:spcPct val="100000"/>
         </a:lnSpc>
@@ -2542,7 +2506,7 @@
           <a:sym typeface="Calibri"/>
         </a:defRPr>
       </a:lvl2pPr>
-      <a:lvl3pPr marL="0" marR="0" indent="914400" algn="r" defTabSz="457200" rtl="0" latinLnBrk="0">
+      <a:lvl3pPr marL="0" marR="0" indent="0" algn="r" defTabSz="457200" rtl="0" latinLnBrk="0">
         <a:lnSpc>
           <a:spcPct val="100000"/>
         </a:lnSpc>
@@ -2568,7 +2532,7 @@
           <a:sym typeface="Calibri"/>
         </a:defRPr>
       </a:lvl3pPr>
-      <a:lvl4pPr marL="0" marR="0" indent="1371600" algn="r" defTabSz="457200" rtl="0" latinLnBrk="0">
+      <a:lvl4pPr marL="0" marR="0" indent="0" algn="r" defTabSz="457200" rtl="0" latinLnBrk="0">
         <a:lnSpc>
           <a:spcPct val="100000"/>
         </a:lnSpc>
@@ -2594,7 +2558,7 @@
           <a:sym typeface="Calibri"/>
         </a:defRPr>
       </a:lvl4pPr>
-      <a:lvl5pPr marL="0" marR="0" indent="1828800" algn="r" defTabSz="457200" rtl="0" latinLnBrk="0">
+      <a:lvl5pPr marL="0" marR="0" indent="0" algn="r" defTabSz="457200" rtl="0" latinLnBrk="0">
         <a:lnSpc>
           <a:spcPct val="100000"/>
         </a:lnSpc>
@@ -2620,7 +2584,7 @@
           <a:sym typeface="Calibri"/>
         </a:defRPr>
       </a:lvl5pPr>
-      <a:lvl6pPr marL="0" marR="0" indent="2286000" algn="r" defTabSz="457200" rtl="0" latinLnBrk="0">
+      <a:lvl6pPr marL="0" marR="0" indent="0" algn="r" defTabSz="457200" rtl="0" latinLnBrk="0">
         <a:lnSpc>
           <a:spcPct val="100000"/>
         </a:lnSpc>
@@ -2646,7 +2610,7 @@
           <a:sym typeface="Calibri"/>
         </a:defRPr>
       </a:lvl6pPr>
-      <a:lvl7pPr marL="0" marR="0" indent="2743200" algn="r" defTabSz="457200" rtl="0" latinLnBrk="0">
+      <a:lvl7pPr marL="0" marR="0" indent="0" algn="r" defTabSz="457200" rtl="0" latinLnBrk="0">
         <a:lnSpc>
           <a:spcPct val="100000"/>
         </a:lnSpc>
@@ -2672,7 +2636,7 @@
           <a:sym typeface="Calibri"/>
         </a:defRPr>
       </a:lvl7pPr>
-      <a:lvl8pPr marL="0" marR="0" indent="3200400" algn="r" defTabSz="457200" rtl="0" latinLnBrk="0">
+      <a:lvl8pPr marL="0" marR="0" indent="0" algn="r" defTabSz="457200" rtl="0" latinLnBrk="0">
         <a:lnSpc>
           <a:spcPct val="100000"/>
         </a:lnSpc>
@@ -2698,7 +2662,7 @@
           <a:sym typeface="Calibri"/>
         </a:defRPr>
       </a:lvl8pPr>
-      <a:lvl9pPr marL="0" marR="0" indent="3657600" algn="r" defTabSz="457200" rtl="0" latinLnBrk="0">
+      <a:lvl9pPr marL="0" marR="0" indent="0" algn="r" defTabSz="457200" rtl="0" latinLnBrk="0">
         <a:lnSpc>
           <a:spcPct val="100000"/>
         </a:lnSpc>
@@ -2775,7 +2739,7 @@
           </a:effectLst>
         </p:spPr>
         <p:txBody>
-          <a:bodyPr lIns="45719" rIns="45719" anchor="ctr"/>
+          <a:bodyPr lIns="45718" tIns="45718" rIns="45718" bIns="45718" anchor="ctr"/>
           <a:lstStyle/>
           <a:p>
             <a:pPr algn="ctr">
@@ -2796,8 +2760,8 @@
         </p:nvSpPr>
         <p:spPr>
           <a:xfrm>
-            <a:off x="777239" y="457199"/>
-            <a:ext cx="2547899" cy="340183"/>
+            <a:off x="777238" y="457199"/>
+            <a:ext cx="2547897" cy="340181"/>
           </a:xfrm>
           <a:prstGeom prst="rect">
             <a:avLst/>
@@ -2812,7 +2776,7 @@
           </a:extLst>
         </p:spPr>
         <p:txBody>
-          <a:bodyPr wrap="none" lIns="45719" rIns="45719">
+          <a:bodyPr wrap="none" lIns="45718" tIns="45718" rIns="45718" bIns="45718">
             <a:spAutoFit/>
           </a:bodyPr>
           <a:lstStyle>
@@ -2841,7 +2805,7 @@
         <p:spPr>
           <a:xfrm>
             <a:off x="777239" y="914400"/>
-            <a:ext cx="7153386" cy="601623"/>
+            <a:ext cx="7153383" cy="601622"/>
           </a:xfrm>
           <a:prstGeom prst="rect">
             <a:avLst/>
@@ -2856,7 +2820,7 @@
           </a:extLst>
         </p:spPr>
         <p:txBody>
-          <a:bodyPr wrap="none" lIns="45719" rIns="45719">
+          <a:bodyPr wrap="none" lIns="45718" tIns="45718" rIns="45718" bIns="45718">
             <a:spAutoFit/>
           </a:bodyPr>
           <a:lstStyle>
@@ -2884,8 +2848,8 @@
         </p:nvSpPr>
         <p:spPr>
           <a:xfrm>
-            <a:off x="777239" y="3108960"/>
-            <a:ext cx="6178121" cy="1694791"/>
+            <a:off x="777239" y="3108961"/>
+            <a:ext cx="6178118" cy="1770989"/>
           </a:xfrm>
           <a:prstGeom prst="rect">
             <a:avLst/>
@@ -2900,7 +2864,7 @@
           </a:extLst>
         </p:spPr>
         <p:txBody>
-          <a:bodyPr wrap="none" lIns="45719" rIns="45719">
+          <a:bodyPr wrap="none" lIns="45718" tIns="45718" rIns="45718" bIns="45718">
             <a:spAutoFit/>
           </a:bodyPr>
           <a:lstStyle/>
@@ -2986,8 +2950,8 @@
         </p:nvSpPr>
         <p:spPr>
           <a:xfrm>
-            <a:off x="6903719" y="3108960"/>
-            <a:ext cx="3614898" cy="1646794"/>
+            <a:off x="6903718" y="3108961"/>
+            <a:ext cx="3614896" cy="1722992"/>
           </a:xfrm>
           <a:prstGeom prst="rect">
             <a:avLst/>
@@ -3002,7 +2966,7 @@
           </a:extLst>
         </p:spPr>
         <p:txBody>
-          <a:bodyPr wrap="none" lIns="45719" rIns="45719">
+          <a:bodyPr wrap="none" lIns="45718" tIns="45718" rIns="45718" bIns="45718">
             <a:spAutoFit/>
           </a:bodyPr>
           <a:lstStyle/>
@@ -3135,7 +3099,7 @@
           </a:effectLst>
         </p:spPr>
         <p:txBody>
-          <a:bodyPr lIns="45719" rIns="45719" anchor="ctr"/>
+          <a:bodyPr lIns="45718" tIns="45718" rIns="45718" bIns="45718" anchor="ctr"/>
           <a:lstStyle/>
           <a:p>
             <a:pPr algn="ctr">
@@ -3157,7 +3121,7 @@
         <p:spPr>
           <a:xfrm>
             <a:off x="594360" y="137159"/>
-            <a:ext cx="10881361" cy="497048"/>
+            <a:ext cx="10881361" cy="497046"/>
           </a:xfrm>
           <a:prstGeom prst="rect">
             <a:avLst/>
@@ -3172,7 +3136,7 @@
           </a:extLst>
         </p:spPr>
         <p:txBody>
-          <a:bodyPr lIns="45719" rIns="45719">
+          <a:bodyPr lIns="45718" tIns="45718" rIns="45718" bIns="45718">
             <a:spAutoFit/>
           </a:bodyPr>
           <a:lstStyle>
@@ -3200,8 +3164,8 @@
         </p:nvSpPr>
         <p:spPr>
           <a:xfrm>
-            <a:off x="594360" y="1371600"/>
-            <a:ext cx="10881361" cy="4124782"/>
+            <a:off x="594360" y="1371601"/>
+            <a:ext cx="10881361" cy="4200980"/>
           </a:xfrm>
           <a:prstGeom prst="rect">
             <a:avLst/>
@@ -3216,7 +3180,7 @@
           </a:extLst>
         </p:spPr>
         <p:txBody>
-          <a:bodyPr lIns="45719" rIns="45719">
+          <a:bodyPr lIns="45718" tIns="45718" rIns="45718" bIns="45718">
             <a:spAutoFit/>
           </a:bodyPr>
           <a:lstStyle/>
@@ -3273,12 +3237,12 @@
               <a:spcBef>
                 <a:spcPts val="600"/>
               </a:spcBef>
+              <a:defRPr sz="2000">
+                <a:solidFill>
+                  <a:srgbClr val="333333"/>
+                </a:solidFill>
+              </a:defRPr>
             </a:pPr>
-            <a:endParaRPr sz="2000">
-              <a:solidFill>
-                <a:srgbClr val="333333"/>
-              </a:solidFill>
-            </a:endParaRPr>
           </a:p>
           <a:p>
             <a:pPr>
@@ -3311,7 +3275,7 @@
             </a:r>
           </a:p>
           <a:p>
-            <a:pPr lvl="1">
+            <a:pPr lvl="1" indent="457200">
               <a:spcBef>
                 <a:spcPts val="600"/>
               </a:spcBef>
@@ -3326,7 +3290,7 @@
             </a:r>
           </a:p>
           <a:p>
-            <a:pPr lvl="1">
+            <a:pPr lvl="1" indent="457200">
               <a:spcBef>
                 <a:spcPts val="600"/>
               </a:spcBef>
@@ -3345,12 +3309,12 @@
               <a:spcBef>
                 <a:spcPts val="600"/>
               </a:spcBef>
+              <a:defRPr>
+                <a:solidFill>
+                  <a:srgbClr val="333333"/>
+                </a:solidFill>
+              </a:defRPr>
             </a:pPr>
-            <a:endParaRPr>
-              <a:solidFill>
-                <a:srgbClr val="333333"/>
-              </a:solidFill>
-            </a:endParaRPr>
           </a:p>
           <a:p>
             <a:pPr>
@@ -3424,7 +3388,7 @@
           </a:effectLst>
         </p:spPr>
         <p:txBody>
-          <a:bodyPr lIns="45719" rIns="45719" anchor="ctr"/>
+          <a:bodyPr lIns="45718" tIns="45718" rIns="45718" bIns="45718" anchor="ctr"/>
           <a:lstStyle/>
           <a:p>
             <a:pPr algn="ctr">
@@ -3446,7 +3410,7 @@
         <p:spPr>
           <a:xfrm>
             <a:off x="594360" y="137159"/>
-            <a:ext cx="10881361" cy="497048"/>
+            <a:ext cx="10881361" cy="497046"/>
           </a:xfrm>
           <a:prstGeom prst="rect">
             <a:avLst/>
@@ -3461,7 +3425,7 @@
           </a:extLst>
         </p:spPr>
         <p:txBody>
-          <a:bodyPr lIns="45719" rIns="45719">
+          <a:bodyPr lIns="45718" tIns="45718" rIns="45718" bIns="45718">
             <a:spAutoFit/>
           </a:bodyPr>
           <a:lstStyle>
@@ -3489,8 +3453,8 @@
         </p:nvSpPr>
         <p:spPr>
           <a:xfrm>
-            <a:off x="594360" y="1371600"/>
-            <a:ext cx="5394961" cy="4117241"/>
+            <a:off x="594359" y="1371601"/>
+            <a:ext cx="5394962" cy="4193439"/>
           </a:xfrm>
           <a:prstGeom prst="rect">
             <a:avLst/>
@@ -3505,7 +3469,7 @@
           </a:extLst>
         </p:spPr>
         <p:txBody>
-          <a:bodyPr lIns="45719" rIns="45719">
+          <a:bodyPr lIns="45718" tIns="45718" rIns="45718" bIns="45718">
             <a:spAutoFit/>
           </a:bodyPr>
           <a:lstStyle/>
@@ -3753,8 +3717,8 @@
         </p:nvSpPr>
         <p:spPr>
           <a:xfrm>
-            <a:off x="6446519" y="2743200"/>
-            <a:ext cx="4542370" cy="444758"/>
+            <a:off x="6446518" y="2743200"/>
+            <a:ext cx="4542368" cy="444757"/>
           </a:xfrm>
           <a:prstGeom prst="rect">
             <a:avLst/>
@@ -3769,7 +3733,7 @@
           </a:extLst>
         </p:spPr>
         <p:txBody>
-          <a:bodyPr wrap="none" lIns="45719" rIns="45719">
+          <a:bodyPr wrap="none" lIns="45718" tIns="45718" rIns="45718" bIns="45718">
             <a:spAutoFit/>
           </a:bodyPr>
           <a:lstStyle>
@@ -3844,7 +3808,7 @@
           </a:effectLst>
         </p:spPr>
         <p:txBody>
-          <a:bodyPr lIns="45719" rIns="45719" anchor="ctr"/>
+          <a:bodyPr lIns="45718" tIns="45718" rIns="45718" bIns="45718" anchor="ctr"/>
           <a:lstStyle/>
           <a:p>
             <a:pPr algn="ctr">
@@ -3866,7 +3830,7 @@
         <p:spPr>
           <a:xfrm>
             <a:off x="594360" y="137159"/>
-            <a:ext cx="10881361" cy="497048"/>
+            <a:ext cx="10881361" cy="497046"/>
           </a:xfrm>
           <a:prstGeom prst="rect">
             <a:avLst/>
@@ -3881,7 +3845,7 @@
           </a:extLst>
         </p:spPr>
         <p:txBody>
-          <a:bodyPr lIns="45719" rIns="45719">
+          <a:bodyPr lIns="45718" tIns="45718" rIns="45718" bIns="45718">
             <a:spAutoFit/>
           </a:bodyPr>
           <a:lstStyle>
@@ -3909,8 +3873,8 @@
         </p:nvSpPr>
         <p:spPr>
           <a:xfrm>
-            <a:off x="594360" y="1371600"/>
-            <a:ext cx="5852161" cy="2847688"/>
+            <a:off x="594359" y="1371600"/>
+            <a:ext cx="5852162" cy="2923887"/>
           </a:xfrm>
           <a:prstGeom prst="rect">
             <a:avLst/>
@@ -3925,7 +3889,7 @@
           </a:extLst>
         </p:spPr>
         <p:txBody>
-          <a:bodyPr lIns="45719" rIns="45719">
+          <a:bodyPr lIns="45718" tIns="45718" rIns="45718" bIns="45718">
             <a:spAutoFit/>
           </a:bodyPr>
           <a:lstStyle/>
@@ -4047,8 +4011,8 @@
         </p:nvSpPr>
         <p:spPr>
           <a:xfrm>
-            <a:off x="6903719" y="1371600"/>
-            <a:ext cx="4937762" cy="1742788"/>
+            <a:off x="6903718" y="1371600"/>
+            <a:ext cx="4937763" cy="1818987"/>
           </a:xfrm>
           <a:prstGeom prst="rect">
             <a:avLst/>
@@ -4063,7 +4027,7 @@
           </a:extLst>
         </p:spPr>
         <p:txBody>
-          <a:bodyPr lIns="45719" rIns="45719">
+          <a:bodyPr lIns="45718" tIns="45718" rIns="45718" bIns="45718">
             <a:spAutoFit/>
           </a:bodyPr>
           <a:lstStyle/>
@@ -4187,7 +4151,7 @@
           </a:effectLst>
         </p:spPr>
         <p:txBody>
-          <a:bodyPr lIns="45719" rIns="45719" anchor="ctr"/>
+          <a:bodyPr lIns="45718" tIns="45718" rIns="45718" bIns="45718" anchor="ctr"/>
           <a:lstStyle/>
           <a:p>
             <a:pPr algn="ctr">
@@ -4209,7 +4173,7 @@
         <p:spPr>
           <a:xfrm>
             <a:off x="594360" y="137159"/>
-            <a:ext cx="10881361" cy="497048"/>
+            <a:ext cx="10881361" cy="497046"/>
           </a:xfrm>
           <a:prstGeom prst="rect">
             <a:avLst/>
@@ -4224,7 +4188,7 @@
           </a:extLst>
         </p:spPr>
         <p:txBody>
-          <a:bodyPr lIns="45719" rIns="45719">
+          <a:bodyPr lIns="45718" tIns="45718" rIns="45718" bIns="45718">
             <a:spAutoFit/>
           </a:bodyPr>
           <a:lstStyle>
@@ -4252,8 +4216,8 @@
         </p:nvSpPr>
         <p:spPr>
           <a:xfrm>
-            <a:off x="594360" y="1371600"/>
-            <a:ext cx="10881361" cy="3759285"/>
+            <a:off x="594360" y="1371601"/>
+            <a:ext cx="10881361" cy="3835483"/>
           </a:xfrm>
           <a:prstGeom prst="rect">
             <a:avLst/>
@@ -4268,7 +4232,7 @@
           </a:extLst>
         </p:spPr>
         <p:txBody>
-          <a:bodyPr lIns="45719" rIns="45719">
+          <a:bodyPr lIns="45718" tIns="45718" rIns="45718" bIns="45718">
             <a:spAutoFit/>
           </a:bodyPr>
           <a:lstStyle/>
@@ -4325,12 +4289,12 @@
               <a:spcBef>
                 <a:spcPts val="600"/>
               </a:spcBef>
+              <a:defRPr sz="1900">
+                <a:solidFill>
+                  <a:srgbClr val="333333"/>
+                </a:solidFill>
+              </a:defRPr>
             </a:pPr>
-            <a:endParaRPr sz="1900">
-              <a:solidFill>
-                <a:srgbClr val="333333"/>
-              </a:solidFill>
-            </a:endParaRPr>
           </a:p>
           <a:p>
             <a:pPr>
@@ -4367,12 +4331,12 @@
               <a:spcBef>
                 <a:spcPts val="600"/>
               </a:spcBef>
+              <a:defRPr sz="1900">
+                <a:solidFill>
+                  <a:srgbClr val="333333"/>
+                </a:solidFill>
+              </a:defRPr>
             </a:pPr>
-            <a:endParaRPr sz="1900">
-              <a:solidFill>
-                <a:srgbClr val="333333"/>
-              </a:solidFill>
-            </a:endParaRPr>
           </a:p>
           <a:p>
             <a:pPr>
@@ -4461,7 +4425,7 @@
           </a:effectLst>
         </p:spPr>
         <p:txBody>
-          <a:bodyPr lIns="45719" rIns="45719" anchor="ctr"/>
+          <a:bodyPr lIns="45718" tIns="45718" rIns="45718" bIns="45718" anchor="ctr"/>
           <a:lstStyle/>
           <a:p>
             <a:pPr algn="ctr">
@@ -4483,7 +4447,7 @@
         <p:spPr>
           <a:xfrm>
             <a:off x="594360" y="137159"/>
-            <a:ext cx="10881361" cy="497048"/>
+            <a:ext cx="10881361" cy="497046"/>
           </a:xfrm>
           <a:prstGeom prst="rect">
             <a:avLst/>
@@ -4498,7 +4462,7 @@
           </a:extLst>
         </p:spPr>
         <p:txBody>
-          <a:bodyPr lIns="45719" rIns="45719">
+          <a:bodyPr lIns="45718" tIns="45718" rIns="45718" bIns="45718">
             <a:spAutoFit/>
           </a:bodyPr>
           <a:lstStyle>
@@ -4551,7 +4515,7 @@
           </a:effectLst>
         </p:spPr>
         <p:txBody>
-          <a:bodyPr lIns="45719" rIns="45719" anchor="ctr"/>
+          <a:bodyPr lIns="45718" tIns="45718" rIns="45718" bIns="45718" anchor="ctr"/>
           <a:lstStyle/>
           <a:p>
             <a:pPr algn="ctr">
@@ -4572,8 +4536,8 @@
         </p:nvSpPr>
         <p:spPr>
           <a:xfrm>
-            <a:off x="801416" y="1713229"/>
-            <a:ext cx="5865798" cy="3431541"/>
+            <a:off x="801415" y="1713229"/>
+            <a:ext cx="6688891" cy="3990339"/>
           </a:xfrm>
           <a:prstGeom prst="rect">
             <a:avLst/>
@@ -4588,7 +4552,7 @@
           </a:extLst>
         </p:spPr>
         <p:txBody>
-          <a:bodyPr wrap="none" lIns="45719" rIns="45719">
+          <a:bodyPr wrap="none" lIns="45718" tIns="45718" rIns="45718" bIns="45718">
             <a:spAutoFit/>
           </a:bodyPr>
           <a:lstStyle/>
@@ -4597,7 +4561,7 @@
               <a:spcBef>
                 <a:spcPts val="100"/>
               </a:spcBef>
-              <a:defRPr sz="2100">
+              <a:defRPr sz="2400">
                 <a:solidFill>
                   <a:srgbClr val="333333"/>
                 </a:solidFill>
@@ -4616,7 +4580,7 @@
               <a:spcBef>
                 <a:spcPts val="100"/>
               </a:spcBef>
-              <a:defRPr sz="2100">
+              <a:defRPr sz="2400">
                 <a:solidFill>
                   <a:srgbClr val="333333"/>
                 </a:solidFill>
@@ -4635,7 +4599,7 @@
               <a:spcBef>
                 <a:spcPts val="100"/>
               </a:spcBef>
-              <a:defRPr sz="2100">
+              <a:defRPr sz="2400">
                 <a:solidFill>
                   <a:srgbClr val="333333"/>
                 </a:solidFill>
@@ -4651,7 +4615,7 @@
               <a:spcBef>
                 <a:spcPts val="100"/>
               </a:spcBef>
-              <a:defRPr sz="2100">
+              <a:defRPr sz="2400">
                 <a:solidFill>
                   <a:srgbClr val="333333"/>
                 </a:solidFill>
@@ -4670,7 +4634,7 @@
               <a:spcBef>
                 <a:spcPts val="100"/>
               </a:spcBef>
-              <a:defRPr sz="2100">
+              <a:defRPr sz="2400">
                 <a:solidFill>
                   <a:srgbClr val="333333"/>
                 </a:solidFill>
@@ -4689,7 +4653,7 @@
               <a:spcBef>
                 <a:spcPts val="100"/>
               </a:spcBef>
-              <a:defRPr sz="2100">
+              <a:defRPr sz="2400">
                 <a:solidFill>
                   <a:srgbClr val="333333"/>
                 </a:solidFill>
@@ -4705,7 +4669,7 @@
               <a:spcBef>
                 <a:spcPts val="100"/>
               </a:spcBef>
-              <a:defRPr sz="2100">
+              <a:defRPr sz="2400">
                 <a:solidFill>
                   <a:srgbClr val="333333"/>
                 </a:solidFill>
@@ -4724,7 +4688,7 @@
               <a:spcBef>
                 <a:spcPts val="100"/>
               </a:spcBef>
-              <a:defRPr sz="2100">
+              <a:defRPr sz="2400">
                 <a:solidFill>
                   <a:srgbClr val="333333"/>
                 </a:solidFill>
@@ -4743,7 +4707,7 @@
               <a:spcBef>
                 <a:spcPts val="100"/>
               </a:spcBef>
-              <a:defRPr sz="2100">
+              <a:defRPr sz="2400">
                 <a:solidFill>
                   <a:srgbClr val="333333"/>
                 </a:solidFill>
@@ -4762,7 +4726,7 @@
               <a:spcBef>
                 <a:spcPts val="100"/>
               </a:spcBef>
-              <a:defRPr sz="2100">
+              <a:defRPr sz="2400">
                 <a:solidFill>
                   <a:srgbClr val="333333"/>
                 </a:solidFill>
@@ -4778,7 +4742,7 @@
               <a:spcBef>
                 <a:spcPts val="100"/>
               </a:spcBef>
-              <a:defRPr sz="2100">
+              <a:defRPr sz="2400">
                 <a:solidFill>
                   <a:srgbClr val="333333"/>
                 </a:solidFill>
@@ -4802,8 +4766,8 @@
         </p:nvSpPr>
         <p:spPr>
           <a:xfrm>
-            <a:off x="8092439" y="1371600"/>
-            <a:ext cx="3749041" cy="1986891"/>
+            <a:off x="8092439" y="1371601"/>
+            <a:ext cx="3749042" cy="2063089"/>
           </a:xfrm>
           <a:prstGeom prst="rect">
             <a:avLst/>
@@ -4818,7 +4782,7 @@
           </a:extLst>
         </p:spPr>
         <p:txBody>
-          <a:bodyPr lIns="45719" rIns="45719">
+          <a:bodyPr lIns="45718" tIns="45718" rIns="45718" bIns="45718">
             <a:spAutoFit/>
           </a:bodyPr>
           <a:lstStyle/>
@@ -4860,12 +4824,12 @@
               <a:spcBef>
                 <a:spcPts val="600"/>
               </a:spcBef>
+              <a:defRPr>
+                <a:solidFill>
+                  <a:srgbClr val="333333"/>
+                </a:solidFill>
+              </a:defRPr>
             </a:pPr>
-            <a:endParaRPr>
-              <a:solidFill>
-                <a:srgbClr val="333333"/>
-              </a:solidFill>
-            </a:endParaRPr>
           </a:p>
           <a:p>
             <a:pPr>
@@ -4939,7 +4903,7 @@
           </a:effectLst>
         </p:spPr>
         <p:txBody>
-          <a:bodyPr lIns="45719" rIns="45719" anchor="ctr"/>
+          <a:bodyPr lIns="45718" tIns="45718" rIns="45718" bIns="45718" anchor="ctr"/>
           <a:lstStyle/>
           <a:p>
             <a:pPr algn="ctr">
@@ -4961,7 +4925,7 @@
         <p:spPr>
           <a:xfrm>
             <a:off x="594360" y="137159"/>
-            <a:ext cx="10881361" cy="497048"/>
+            <a:ext cx="10881361" cy="497046"/>
           </a:xfrm>
           <a:prstGeom prst="rect">
             <a:avLst/>
@@ -4976,7 +4940,7 @@
           </a:extLst>
         </p:spPr>
         <p:txBody>
-          <a:bodyPr lIns="45719" rIns="45719">
+          <a:bodyPr lIns="45718" tIns="45718" rIns="45718" bIns="45718">
             <a:spAutoFit/>
           </a:bodyPr>
           <a:lstStyle>
@@ -5004,8 +4968,8 @@
         </p:nvSpPr>
         <p:spPr>
           <a:xfrm>
-            <a:off x="594360" y="1280160"/>
-            <a:ext cx="10881361" cy="333088"/>
+            <a:off x="594360" y="1280161"/>
+            <a:ext cx="10881361" cy="333086"/>
           </a:xfrm>
           <a:prstGeom prst="rect">
             <a:avLst/>
@@ -5020,7 +4984,7 @@
           </a:extLst>
         </p:spPr>
         <p:txBody>
-          <a:bodyPr lIns="45719" rIns="45719">
+          <a:bodyPr lIns="45718" tIns="45718" rIns="45718" bIns="45718">
             <a:spAutoFit/>
           </a:bodyPr>
           <a:lstStyle>
@@ -5283,7 +5247,7 @@
         <p:spPr>
           <a:xfrm>
             <a:off x="594360" y="4571999"/>
-            <a:ext cx="8161447" cy="340183"/>
+            <a:ext cx="8161445" cy="340181"/>
           </a:xfrm>
           <a:prstGeom prst="rect">
             <a:avLst/>
@@ -5298,7 +5262,7 @@
           </a:extLst>
         </p:spPr>
         <p:txBody>
-          <a:bodyPr wrap="none" lIns="45719" rIns="45719">
+          <a:bodyPr wrap="none" lIns="45718" tIns="45718" rIns="45718" bIns="45718">
             <a:spAutoFit/>
           </a:bodyPr>
           <a:lstStyle>
@@ -5373,7 +5337,7 @@
           </a:effectLst>
         </p:spPr>
         <p:txBody>
-          <a:bodyPr lIns="45719" rIns="45719" anchor="ctr"/>
+          <a:bodyPr lIns="45718" tIns="45718" rIns="45718" bIns="45718" anchor="ctr"/>
           <a:lstStyle/>
           <a:p>
             <a:pPr algn="ctr">
@@ -5395,7 +5359,7 @@
         <p:spPr>
           <a:xfrm>
             <a:off x="594360" y="137159"/>
-            <a:ext cx="10881361" cy="497048"/>
+            <a:ext cx="10881361" cy="497046"/>
           </a:xfrm>
           <a:prstGeom prst="rect">
             <a:avLst/>
@@ -5410,7 +5374,7 @@
           </a:extLst>
         </p:spPr>
         <p:txBody>
-          <a:bodyPr lIns="45719" rIns="45719">
+          <a:bodyPr lIns="45718" tIns="45718" rIns="45718" bIns="45718">
             <a:spAutoFit/>
           </a:bodyPr>
           <a:lstStyle>
@@ -5437,8 +5401,8 @@
           <p:nvPr/>
         </p:nvGraphicFramePr>
         <p:xfrm>
-          <a:off x="365759" y="1371600"/>
-          <a:ext cx="10515601" cy="3017521"/>
+          <a:off x="365758" y="1371600"/>
+          <a:ext cx="10515602" cy="3017522"/>
         </p:xfrm>
         <a:graphic xmlns:a="http://schemas.openxmlformats.org/drawingml/2006/main">
           <a:graphicData uri="http://schemas.openxmlformats.org/drawingml/2006/table">
@@ -5753,7 +5717,7 @@
           </a:effectLst>
         </p:spPr>
         <p:txBody>
-          <a:bodyPr lIns="45719" rIns="45719" anchor="ctr"/>
+          <a:bodyPr lIns="45718" tIns="45718" rIns="45718" bIns="45718" anchor="ctr"/>
           <a:lstStyle/>
           <a:p>
             <a:pPr algn="ctr">
@@ -5775,7 +5739,7 @@
         <p:spPr>
           <a:xfrm>
             <a:off x="594360" y="137159"/>
-            <a:ext cx="10881361" cy="497048"/>
+            <a:ext cx="10881361" cy="497046"/>
           </a:xfrm>
           <a:prstGeom prst="rect">
             <a:avLst/>
@@ -5790,7 +5754,7 @@
           </a:extLst>
         </p:spPr>
         <p:txBody>
-          <a:bodyPr lIns="45719" rIns="45719">
+          <a:bodyPr lIns="45718" tIns="45718" rIns="45718" bIns="45718">
             <a:spAutoFit/>
           </a:bodyPr>
           <a:lstStyle>
@@ -6361,7 +6325,7 @@
           </a:effectLst>
         </p:spPr>
         <p:txBody>
-          <a:bodyPr lIns="45719" rIns="45719" anchor="ctr"/>
+          <a:bodyPr lIns="45718" tIns="45718" rIns="45718" bIns="45718" anchor="ctr"/>
           <a:lstStyle/>
           <a:p>
             <a:pPr algn="ctr">
@@ -6383,7 +6347,7 @@
         <p:spPr>
           <a:xfrm>
             <a:off x="594360" y="137159"/>
-            <a:ext cx="10881361" cy="497048"/>
+            <a:ext cx="10881361" cy="497046"/>
           </a:xfrm>
           <a:prstGeom prst="rect">
             <a:avLst/>
@@ -6398,7 +6362,7 @@
           </a:extLst>
         </p:spPr>
         <p:txBody>
-          <a:bodyPr lIns="45719" rIns="45719">
+          <a:bodyPr lIns="45718" tIns="45718" rIns="45718" bIns="45718">
             <a:spAutoFit/>
           </a:bodyPr>
           <a:lstStyle>
@@ -6426,8 +6390,8 @@
         </p:nvSpPr>
         <p:spPr>
           <a:xfrm>
-            <a:off x="594360" y="1371600"/>
-            <a:ext cx="10881361" cy="3350082"/>
+            <a:off x="594360" y="1371601"/>
+            <a:ext cx="10881361" cy="3426280"/>
           </a:xfrm>
           <a:prstGeom prst="rect">
             <a:avLst/>
@@ -6442,7 +6406,7 @@
           </a:extLst>
         </p:spPr>
         <p:txBody>
-          <a:bodyPr lIns="45719" rIns="45719">
+          <a:bodyPr lIns="45718" tIns="45718" rIns="45718" bIns="45718">
             <a:spAutoFit/>
           </a:bodyPr>
           <a:lstStyle/>
@@ -6544,12 +6508,12 @@
               <a:spcBef>
                 <a:spcPts val="600"/>
               </a:spcBef>
+              <a:defRPr sz="2000">
+                <a:solidFill>
+                  <a:srgbClr val="333333"/>
+                </a:solidFill>
+              </a:defRPr>
             </a:pPr>
-            <a:endParaRPr sz="2000">
-              <a:solidFill>
-                <a:srgbClr val="333333"/>
-              </a:solidFill>
-            </a:endParaRPr>
           </a:p>
           <a:p>
             <a:pPr>
@@ -6722,9 +6686,9 @@
         </a:effectStyle>
         <a:effectStyle>
           <a:effectLst>
-            <a:outerShdw sx="100000" sy="100000" kx="0" ky="0" algn="b" rotWithShape="0" blurRad="38100" dist="20000" dir="5400000">
+            <a:outerShdw sx="100000" sy="100000" kx="0" ky="0" algn="b" rotWithShape="0" blurRad="38100" dist="23000" dir="5400000">
               <a:srgbClr val="000000">
-                <a:alpha val="38000"/>
+                <a:alpha val="35000"/>
               </a:srgbClr>
             </a:outerShdw>
           </a:effectLst>
@@ -6804,7 +6768,7 @@
         </a:effectLst>
         <a:sp3d/>
       </a:spPr>
-      <a:bodyPr rot="0" spcFirstLastPara="1" vertOverflow="overflow" horzOverflow="overflow" vert="horz" wrap="square" lIns="45719" tIns="45719" rIns="45719" bIns="45719" numCol="1" spcCol="38100" rtlCol="0" anchor="ctr" upright="0">
+      <a:bodyPr rot="0" spcFirstLastPara="1" vertOverflow="overflow" horzOverflow="overflow" vert="horz" wrap="square" lIns="45718" tIns="45718" rIns="45718" bIns="45718" numCol="1" spcCol="38100" rtlCol="0" anchor="ctr" upright="0">
         <a:spAutoFit/>
       </a:bodyPr>
       <a:lstStyle>
@@ -7091,9 +7055,9 @@
           <a:round/>
         </a:ln>
         <a:effectLst>
-          <a:outerShdw sx="100000" sy="100000" kx="0" ky="0" algn="b" rotWithShape="0" blurRad="38100" dist="20000" dir="5400000">
+          <a:outerShdw sx="100000" sy="100000" kx="0" ky="0" algn="b" rotWithShape="0" blurRad="38100" dist="23000" dir="5400000">
             <a:srgbClr val="000000">
-              <a:alpha val="38000"/>
+              <a:alpha val="35000"/>
             </a:srgbClr>
           </a:outerShdw>
         </a:effectLst>
@@ -7381,7 +7345,7 @@
         <a:effectLst/>
         <a:sp3d/>
       </a:spPr>
-      <a:bodyPr rot="0" spcFirstLastPara="1" vertOverflow="overflow" horzOverflow="overflow" vert="horz" wrap="square" lIns="45719" tIns="45719" rIns="45719" bIns="45719" numCol="1" spcCol="38100" rtlCol="0" anchor="t" upright="0">
+      <a:bodyPr rot="0" spcFirstLastPara="1" vertOverflow="overflow" horzOverflow="overflow" vert="horz" wrap="square" lIns="45718" tIns="45718" rIns="45718" bIns="45718" numCol="1" spcCol="38100" rtlCol="0" anchor="t" upright="0">
         <a:spAutoFit/>
       </a:bodyPr>
       <a:lstStyle>
@@ -7806,9 +7770,9 @@
         </a:effectStyle>
         <a:effectStyle>
           <a:effectLst>
-            <a:outerShdw sx="100000" sy="100000" kx="0" ky="0" algn="b" rotWithShape="0" blurRad="38100" dist="20000" dir="5400000">
+            <a:outerShdw sx="100000" sy="100000" kx="0" ky="0" algn="b" rotWithShape="0" blurRad="38100" dist="23000" dir="5400000">
               <a:srgbClr val="000000">
-                <a:alpha val="38000"/>
+                <a:alpha val="35000"/>
               </a:srgbClr>
             </a:outerShdw>
           </a:effectLst>
@@ -7888,7 +7852,7 @@
         </a:effectLst>
         <a:sp3d/>
       </a:spPr>
-      <a:bodyPr rot="0" spcFirstLastPara="1" vertOverflow="overflow" horzOverflow="overflow" vert="horz" wrap="square" lIns="45719" tIns="45719" rIns="45719" bIns="45719" numCol="1" spcCol="38100" rtlCol="0" anchor="ctr" upright="0">
+      <a:bodyPr rot="0" spcFirstLastPara="1" vertOverflow="overflow" horzOverflow="overflow" vert="horz" wrap="square" lIns="45718" tIns="45718" rIns="45718" bIns="45718" numCol="1" spcCol="38100" rtlCol="0" anchor="ctr" upright="0">
         <a:spAutoFit/>
       </a:bodyPr>
       <a:lstStyle>
@@ -8175,9 +8139,9 @@
           <a:round/>
         </a:ln>
         <a:effectLst>
-          <a:outerShdw sx="100000" sy="100000" kx="0" ky="0" algn="b" rotWithShape="0" blurRad="38100" dist="20000" dir="5400000">
+          <a:outerShdw sx="100000" sy="100000" kx="0" ky="0" algn="b" rotWithShape="0" blurRad="38100" dist="23000" dir="5400000">
             <a:srgbClr val="000000">
-              <a:alpha val="38000"/>
+              <a:alpha val="35000"/>
             </a:srgbClr>
           </a:outerShdw>
         </a:effectLst>
@@ -8465,7 +8429,7 @@
         <a:effectLst/>
         <a:sp3d/>
       </a:spPr>
-      <a:bodyPr rot="0" spcFirstLastPara="1" vertOverflow="overflow" horzOverflow="overflow" vert="horz" wrap="square" lIns="45719" tIns="45719" rIns="45719" bIns="45719" numCol="1" spcCol="38100" rtlCol="0" anchor="t" upright="0">
+      <a:bodyPr rot="0" spcFirstLastPara="1" vertOverflow="overflow" horzOverflow="overflow" vert="horz" wrap="square" lIns="45718" tIns="45718" rIns="45718" bIns="45718" numCol="1" spcCol="38100" rtlCol="0" anchor="t" upright="0">
         <a:spAutoFit/>
       </a:bodyPr>
       <a:lstStyle>

</xml_diff>